<commit_message>
Day 2 deck: ten minutes a day on Where the Money Is, no owner column; Before You Leave to Open Decisions
Co-Authored-By: Claude Opus 5.5 <noreply@anthropic.com>
Claude-Session: https://claude.ai/code/session_01Xa4nFVxuQGXmHARGph9WhS
</commit_message>
<xml_diff>
--- a/day2-deck/decks/Where the Money Is - Review.pptx
+++ b/day2-deck/decks/Where the Money Is - Review.pptx
@@ -502,7 +502,7 @@
           <a:p>
             <a:r>
               <a:rPr lang="en-US" dirty="0"/>
-              <a:t>Source: Labor + parts gross a year, each from its own slide: Technician Proficiency (each tech under 85% raised to 85%, monthly x 12), Hours per RO (0.1 hr x CP ROs at each store's gross per hour), Op Codes (stores under each benchmark brought to it), One More CP RO a Day (307 open days), Tech Minute (one minute per tech per day). Jan-Sep 2026, same-store, 33 stores. The levers overlap - op code services are part of hours per RO, and selling more hours needs tech time - so they are not added together.Talk track: the GM owns the conditions - staffing, pay plans, marketing budget, the parts department. The service manager owns the daily process - dispatch, the inspection, the menu, the drive. Each line has its own slide earlier in the day.</a:t>
+              <a:t>Source: Labor + parts gross a year, each from its own slide: Technician Proficiency (each tech under 85% raised to 85%, monthly x 12), Hours per RO (0.1 hr x CP ROs at each store's gross per hour), Op Codes (stores under each benchmark brought to it), One More CP RO a Day (307 open days), Tech Minute (ten minutes per tech per day). Jan-Sep 2026, same-store, 33 stores. The levers overlap - op code services are part of hours per RO, and selling more hours needs tech time - so they are not added together.Talk track: every line is the GM's and the service manager's together (Noah, Oct 27). Each line has its own slide earlier in the day.</a:t>
             </a:r>
             <a:endParaRPr lang="en-US" dirty="0"/>
           </a:p>
@@ -1080,7 +1080,7 @@
         <p:spPr>
           <a:xfrm>
             <a:off x="7178040" y="1353312"/>
-            <a:ext cx="2651760" cy="310896"/>
+            <a:ext cx="4389120" cy="310896"/>
           </a:xfrm>
           <a:prstGeom prst="rect">
             <a:avLst/>
@@ -1112,42 +1112,23 @@
       </p:sp>
       <p:sp>
         <p:nvSpPr>
-          <p:cNvPr id="9" name="Text 7"/>
-          <p:cNvSpPr txBox="1"/>
-          <p:nvPr/>
-        </p:nvSpPr>
-        <p:spPr>
-          <a:xfrm>
-            <a:off x="9875520" y="1353312"/>
-            <a:ext cx="1691640" cy="310896"/>
-          </a:xfrm>
-          <a:prstGeom prst="rect">
-            <a:avLst/>
-          </a:prstGeom>
-          <a:noFill/>
-          <a:ln/>
-        </p:spPr>
-        <p:txBody>
-          <a:bodyPr wrap="square" lIns="0" tIns="0" rIns="0" bIns="0" rtlCol="0" anchor="ctr"/>
-          <a:lstStyle/>
-          <a:p>
-            <a:pPr algn="l" indent="0" marL="0">
-              <a:buNone/>
-            </a:pPr>
-            <a:r>
-              <a:rPr lang="en-US" sz="1400" b="1" spc="100" kern="0" dirty="0">
-                <a:solidFill>
-                  <a:srgbClr val="0B2C4A"/>
-                </a:solidFill>
-                <a:latin typeface="Inter" pitchFamily="34" charset="0"/>
-                <a:ea typeface="Inter" pitchFamily="34" charset="-122"/>
-                <a:cs typeface="Inter" pitchFamily="34" charset="-120"/>
-              </a:rPr>
-              <a:t>WHO OWNS IT</a:t>
-            </a:r>
-            <a:endParaRPr lang="en-US" sz="1400" dirty="0"/>
-          </a:p>
-        </p:txBody>
+          <p:cNvPr id="9" name="Shape 7"/>
+          <p:cNvSpPr/>
+          <p:nvPr/>
+        </p:nvSpPr>
+        <p:spPr>
+          <a:xfrm>
+            <a:off x="548640" y="1755648"/>
+            <a:ext cx="11091672" cy="713232"/>
+          </a:xfrm>
+          <a:prstGeom prst="rect">
+            <a:avLst/>
+          </a:prstGeom>
+          <a:solidFill>
+            <a:srgbClr val="F7F7F7"/>
+          </a:solidFill>
+          <a:ln/>
+        </p:spPr>
       </p:sp>
       <p:sp>
         <p:nvSpPr>
@@ -1158,26 +1139,6 @@
         <p:spPr>
           <a:xfrm>
             <a:off x="548640" y="1755648"/>
-            <a:ext cx="11091672" cy="713232"/>
-          </a:xfrm>
-          <a:prstGeom prst="rect">
-            <a:avLst/>
-          </a:prstGeom>
-          <a:solidFill>
-            <a:srgbClr val="F7F7F7"/>
-          </a:solidFill>
-          <a:ln/>
-        </p:spPr>
-      </p:sp>
-      <p:sp>
-        <p:nvSpPr>
-          <p:cNvPr id="11" name="Shape 9"/>
-          <p:cNvSpPr/>
-          <p:nvPr/>
-        </p:nvSpPr>
-        <p:spPr>
-          <a:xfrm>
-            <a:off x="548640" y="1755648"/>
             <a:ext cx="64008" cy="713232"/>
           </a:xfrm>
           <a:prstGeom prst="rect">
@@ -1191,7 +1152,7 @@
       </p:sp>
       <p:sp>
         <p:nvSpPr>
-          <p:cNvPr id="12" name="Text 10"/>
+          <p:cNvPr id="11" name="Text 9"/>
           <p:cNvSpPr txBox="1"/>
           <p:nvPr/>
         </p:nvSpPr>
@@ -1230,7 +1191,7 @@
       </p:sp>
       <p:sp>
         <p:nvSpPr>
-          <p:cNvPr id="13" name="Text 11"/>
+          <p:cNvPr id="12" name="Text 10"/>
           <p:cNvSpPr txBox="1"/>
           <p:nvPr/>
         </p:nvSpPr>
@@ -1269,14 +1230,14 @@
       </p:sp>
       <p:sp>
         <p:nvSpPr>
-          <p:cNvPr id="14" name="Text 12"/>
+          <p:cNvPr id="13" name="Text 11"/>
           <p:cNvSpPr txBox="1"/>
           <p:nvPr/>
         </p:nvSpPr>
         <p:spPr>
           <a:xfrm>
             <a:off x="7178040" y="1755648"/>
-            <a:ext cx="2606040" cy="713232"/>
+            <a:ext cx="4389120" cy="713232"/>
           </a:xfrm>
           <a:prstGeom prst="rect">
             <a:avLst/>
@@ -1292,7 +1253,7 @@
               <a:buNone/>
             </a:pPr>
             <a:r>
-              <a:rPr lang="en-US" sz="1400" dirty="0">
+              <a:rPr lang="en-US" sz="1600" dirty="0">
                 <a:solidFill>
                   <a:srgbClr val="595959"/>
                 </a:solidFill>
@@ -1302,9 +1263,29 @@
               </a:rPr>
               <a:t>Dispatch, parts staging, approvals, coaching</a:t>
             </a:r>
-            <a:endParaRPr lang="en-US" sz="1400" dirty="0"/>
-          </a:p>
-        </p:txBody>
+            <a:endParaRPr lang="en-US" sz="1600" dirty="0"/>
+          </a:p>
+        </p:txBody>
+      </p:sp>
+      <p:sp>
+        <p:nvSpPr>
+          <p:cNvPr id="14" name="Shape 12"/>
+          <p:cNvSpPr/>
+          <p:nvPr/>
+        </p:nvSpPr>
+        <p:spPr>
+          <a:xfrm>
+            <a:off x="548640" y="2542032"/>
+            <a:ext cx="11091672" cy="713232"/>
+          </a:xfrm>
+          <a:prstGeom prst="rect">
+            <a:avLst/>
+          </a:prstGeom>
+          <a:solidFill>
+            <a:srgbClr val="FFFFFF"/>
+          </a:solidFill>
+          <a:ln/>
+        </p:spPr>
       </p:sp>
       <p:sp>
         <p:nvSpPr>
@@ -1314,158 +1295,6 @@
         </p:nvSpPr>
         <p:spPr>
           <a:xfrm>
-            <a:off x="9875520" y="1810512"/>
-            <a:ext cx="1691640" cy="274320"/>
-          </a:xfrm>
-          <a:prstGeom prst="roundRect">
-            <a:avLst>
-              <a:gd name="adj" fmla="val 20000"/>
-            </a:avLst>
-          </a:prstGeom>
-          <a:solidFill>
-            <a:srgbClr val="EDF4FA"/>
-          </a:solidFill>
-          <a:ln w="9525">
-            <a:solidFill>
-              <a:srgbClr val="0B2C4A"/>
-            </a:solidFill>
-            <a:prstDash val="solid"/>
-          </a:ln>
-        </p:spPr>
-      </p:sp>
-      <p:sp>
-        <p:nvSpPr>
-          <p:cNvPr id="16" name="Text 14"/>
-          <p:cNvSpPr txBox="1"/>
-          <p:nvPr/>
-        </p:nvSpPr>
-        <p:spPr>
-          <a:xfrm>
-            <a:off x="9875520" y="1810512"/>
-            <a:ext cx="1691640" cy="274320"/>
-          </a:xfrm>
-          <a:prstGeom prst="rect">
-            <a:avLst/>
-          </a:prstGeom>
-          <a:noFill/>
-          <a:ln/>
-        </p:spPr>
-        <p:txBody>
-          <a:bodyPr wrap="square" lIns="0" tIns="0" rIns="0" bIns="0" rtlCol="0" anchor="ctr"/>
-          <a:lstStyle/>
-          <a:p>
-            <a:pPr algn="ctr" indent="0" marL="0">
-              <a:buNone/>
-            </a:pPr>
-            <a:r>
-              <a:rPr lang="en-US" sz="1400" b="1" dirty="0">
-                <a:solidFill>
-                  <a:srgbClr val="0B2C4A"/>
-                </a:solidFill>
-                <a:latin typeface="Inter" pitchFamily="34" charset="0"/>
-                <a:ea typeface="Inter" pitchFamily="34" charset="-122"/>
-                <a:cs typeface="Inter" pitchFamily="34" charset="-120"/>
-              </a:rPr>
-              <a:t>Service manager</a:t>
-            </a:r>
-            <a:endParaRPr lang="en-US" sz="1400" dirty="0"/>
-          </a:p>
-        </p:txBody>
-      </p:sp>
-      <p:sp>
-        <p:nvSpPr>
-          <p:cNvPr id="17" name="Shape 15"/>
-          <p:cNvSpPr/>
-          <p:nvPr/>
-        </p:nvSpPr>
-        <p:spPr>
-          <a:xfrm>
-            <a:off x="9875520" y="2139696"/>
-            <a:ext cx="566928" cy="274320"/>
-          </a:xfrm>
-          <a:prstGeom prst="roundRect">
-            <a:avLst>
-              <a:gd name="adj" fmla="val 20000"/>
-            </a:avLst>
-          </a:prstGeom>
-          <a:solidFill>
-            <a:srgbClr val="0B2C4A"/>
-          </a:solidFill>
-          <a:ln w="9525">
-            <a:solidFill>
-              <a:srgbClr val="0B2C4A"/>
-            </a:solidFill>
-            <a:prstDash val="solid"/>
-          </a:ln>
-        </p:spPr>
-      </p:sp>
-      <p:sp>
-        <p:nvSpPr>
-          <p:cNvPr id="18" name="Text 16"/>
-          <p:cNvSpPr txBox="1"/>
-          <p:nvPr/>
-        </p:nvSpPr>
-        <p:spPr>
-          <a:xfrm>
-            <a:off x="9875520" y="2139696"/>
-            <a:ext cx="566928" cy="274320"/>
-          </a:xfrm>
-          <a:prstGeom prst="rect">
-            <a:avLst/>
-          </a:prstGeom>
-          <a:noFill/>
-          <a:ln/>
-        </p:spPr>
-        <p:txBody>
-          <a:bodyPr wrap="square" lIns="0" tIns="0" rIns="0" bIns="0" rtlCol="0" anchor="ctr"/>
-          <a:lstStyle/>
-          <a:p>
-            <a:pPr algn="ctr" indent="0" marL="0">
-              <a:buNone/>
-            </a:pPr>
-            <a:r>
-              <a:rPr lang="en-US" sz="1400" b="1" dirty="0">
-                <a:solidFill>
-                  <a:srgbClr val="FFFFFF"/>
-                </a:solidFill>
-                <a:latin typeface="Inter" pitchFamily="34" charset="0"/>
-                <a:ea typeface="Inter" pitchFamily="34" charset="-122"/>
-                <a:cs typeface="Inter" pitchFamily="34" charset="-120"/>
-              </a:rPr>
-              <a:t>GM</a:t>
-            </a:r>
-            <a:endParaRPr lang="en-US" sz="1400" dirty="0"/>
-          </a:p>
-        </p:txBody>
-      </p:sp>
-      <p:sp>
-        <p:nvSpPr>
-          <p:cNvPr id="19" name="Shape 17"/>
-          <p:cNvSpPr/>
-          <p:nvPr/>
-        </p:nvSpPr>
-        <p:spPr>
-          <a:xfrm>
-            <a:off x="548640" y="2542032"/>
-            <a:ext cx="11091672" cy="713232"/>
-          </a:xfrm>
-          <a:prstGeom prst="rect">
-            <a:avLst/>
-          </a:prstGeom>
-          <a:solidFill>
-            <a:srgbClr val="FFFFFF"/>
-          </a:solidFill>
-          <a:ln/>
-        </p:spPr>
-      </p:sp>
-      <p:sp>
-        <p:nvSpPr>
-          <p:cNvPr id="20" name="Shape 18"/>
-          <p:cNvSpPr/>
-          <p:nvPr/>
-        </p:nvSpPr>
-        <p:spPr>
-          <a:xfrm>
             <a:off x="548640" y="2542032"/>
             <a:ext cx="64008" cy="713232"/>
           </a:xfrm>
@@ -1480,7 +1309,7 @@
       </p:sp>
       <p:sp>
         <p:nvSpPr>
-          <p:cNvPr id="21" name="Text 19"/>
+          <p:cNvPr id="16" name="Text 14"/>
           <p:cNvSpPr txBox="1"/>
           <p:nvPr/>
         </p:nvSpPr>
@@ -1519,7 +1348,7 @@
       </p:sp>
       <p:sp>
         <p:nvSpPr>
-          <p:cNvPr id="22" name="Text 20"/>
+          <p:cNvPr id="17" name="Text 15"/>
           <p:cNvSpPr txBox="1"/>
           <p:nvPr/>
         </p:nvSpPr>
@@ -1558,14 +1387,14 @@
       </p:sp>
       <p:sp>
         <p:nvSpPr>
-          <p:cNvPr id="23" name="Text 21"/>
+          <p:cNvPr id="18" name="Text 16"/>
           <p:cNvSpPr txBox="1"/>
           <p:nvPr/>
         </p:nvSpPr>
         <p:spPr>
           <a:xfrm>
             <a:off x="7178040" y="2542032"/>
-            <a:ext cx="2606040" cy="713232"/>
+            <a:ext cx="4389120" cy="713232"/>
           </a:xfrm>
           <a:prstGeom prst="rect">
             <a:avLst/>
@@ -1581,7 +1410,7 @@
               <a:buNone/>
             </a:pPr>
             <a:r>
-              <a:rPr lang="en-US" sz="1400" dirty="0">
+              <a:rPr lang="en-US" sz="1600" dirty="0">
                 <a:solidFill>
                   <a:srgbClr val="595959"/>
                 </a:solidFill>
@@ -1591,79 +1420,13 @@
               </a:rPr>
               <a:t>MPI on every car, the menu, Road to the Sale</a:t>
             </a:r>
-            <a:endParaRPr lang="en-US" sz="1400" dirty="0"/>
-          </a:p>
-        </p:txBody>
-      </p:sp>
-      <p:sp>
-        <p:nvSpPr>
-          <p:cNvPr id="24" name="Shape 22"/>
-          <p:cNvSpPr/>
-          <p:nvPr/>
-        </p:nvSpPr>
-        <p:spPr>
-          <a:xfrm>
-            <a:off x="9875520" y="2761488"/>
-            <a:ext cx="1691640" cy="274320"/>
-          </a:xfrm>
-          <a:prstGeom prst="roundRect">
-            <a:avLst>
-              <a:gd name="adj" fmla="val 20000"/>
-            </a:avLst>
-          </a:prstGeom>
-          <a:solidFill>
-            <a:srgbClr val="EDF4FA"/>
-          </a:solidFill>
-          <a:ln w="9525">
-            <a:solidFill>
-              <a:srgbClr val="0B2C4A"/>
-            </a:solidFill>
-            <a:prstDash val="solid"/>
-          </a:ln>
-        </p:spPr>
-      </p:sp>
-      <p:sp>
-        <p:nvSpPr>
-          <p:cNvPr id="25" name="Text 23"/>
-          <p:cNvSpPr txBox="1"/>
-          <p:nvPr/>
-        </p:nvSpPr>
-        <p:spPr>
-          <a:xfrm>
-            <a:off x="9875520" y="2761488"/>
-            <a:ext cx="1691640" cy="274320"/>
-          </a:xfrm>
-          <a:prstGeom prst="rect">
-            <a:avLst/>
-          </a:prstGeom>
-          <a:noFill/>
-          <a:ln/>
-        </p:spPr>
-        <p:txBody>
-          <a:bodyPr wrap="square" lIns="0" tIns="0" rIns="0" bIns="0" rtlCol="0" anchor="ctr"/>
-          <a:lstStyle/>
-          <a:p>
-            <a:pPr algn="ctr" indent="0" marL="0">
-              <a:buNone/>
-            </a:pPr>
-            <a:r>
-              <a:rPr lang="en-US" sz="1400" b="1" dirty="0">
-                <a:solidFill>
-                  <a:srgbClr val="0B2C4A"/>
-                </a:solidFill>
-                <a:latin typeface="Inter" pitchFamily="34" charset="0"/>
-                <a:ea typeface="Inter" pitchFamily="34" charset="-122"/>
-                <a:cs typeface="Inter" pitchFamily="34" charset="-120"/>
-              </a:rPr>
-              <a:t>Service manager</a:t>
-            </a:r>
-            <a:endParaRPr lang="en-US" sz="1400" dirty="0"/>
-          </a:p>
-        </p:txBody>
-      </p:sp>
-      <p:sp>
-        <p:nvSpPr>
-          <p:cNvPr id="26" name="Shape 24"/>
+            <a:endParaRPr lang="en-US" sz="1600" dirty="0"/>
+          </a:p>
+        </p:txBody>
+      </p:sp>
+      <p:sp>
+        <p:nvSpPr>
+          <p:cNvPr id="19" name="Shape 17"/>
           <p:cNvSpPr/>
           <p:nvPr/>
         </p:nvSpPr>
@@ -1683,7 +1446,7 @@
       </p:sp>
       <p:sp>
         <p:nvSpPr>
-          <p:cNvPr id="27" name="Shape 25"/>
+          <p:cNvPr id="20" name="Shape 18"/>
           <p:cNvSpPr/>
           <p:nvPr/>
         </p:nvSpPr>
@@ -1703,7 +1466,7 @@
       </p:sp>
       <p:sp>
         <p:nvSpPr>
-          <p:cNvPr id="28" name="Text 26"/>
+          <p:cNvPr id="21" name="Text 19"/>
           <p:cNvSpPr txBox="1"/>
           <p:nvPr/>
         </p:nvSpPr>
@@ -1742,7 +1505,7 @@
       </p:sp>
       <p:sp>
         <p:nvSpPr>
-          <p:cNvPr id="29" name="Text 27"/>
+          <p:cNvPr id="22" name="Text 20"/>
           <p:cNvSpPr txBox="1"/>
           <p:nvPr/>
         </p:nvSpPr>
@@ -1781,14 +1544,14 @@
       </p:sp>
       <p:sp>
         <p:nvSpPr>
-          <p:cNvPr id="30" name="Text 28"/>
+          <p:cNvPr id="23" name="Text 21"/>
           <p:cNvSpPr txBox="1"/>
           <p:nvPr/>
         </p:nvSpPr>
         <p:spPr>
           <a:xfrm>
             <a:off x="7178040" y="3328416"/>
-            <a:ext cx="2606040" cy="713232"/>
+            <a:ext cx="4389120" cy="713232"/>
           </a:xfrm>
           <a:prstGeom prst="rect">
             <a:avLst/>
@@ -1804,7 +1567,7 @@
               <a:buNone/>
             </a:pPr>
             <a:r>
-              <a:rPr lang="en-US" sz="1400" dirty="0">
+              <a:rPr lang="en-US" sz="1600" dirty="0">
                 <a:solidFill>
                   <a:srgbClr val="595959"/>
                 </a:solidFill>
@@ -1814,79 +1577,13 @@
               </a:rPr>
               <a:t>Alignment, balance, brake fluid, fuel service</a:t>
             </a:r>
-            <a:endParaRPr lang="en-US" sz="1400" dirty="0"/>
-          </a:p>
-        </p:txBody>
-      </p:sp>
-      <p:sp>
-        <p:nvSpPr>
-          <p:cNvPr id="31" name="Shape 29"/>
-          <p:cNvSpPr/>
-          <p:nvPr/>
-        </p:nvSpPr>
-        <p:spPr>
-          <a:xfrm>
-            <a:off x="9875520" y="3547872"/>
-            <a:ext cx="1691640" cy="274320"/>
-          </a:xfrm>
-          <a:prstGeom prst="roundRect">
-            <a:avLst>
-              <a:gd name="adj" fmla="val 20000"/>
-            </a:avLst>
-          </a:prstGeom>
-          <a:solidFill>
-            <a:srgbClr val="EDF4FA"/>
-          </a:solidFill>
-          <a:ln w="9525">
-            <a:solidFill>
-              <a:srgbClr val="0B2C4A"/>
-            </a:solidFill>
-            <a:prstDash val="solid"/>
-          </a:ln>
-        </p:spPr>
-      </p:sp>
-      <p:sp>
-        <p:nvSpPr>
-          <p:cNvPr id="32" name="Text 30"/>
-          <p:cNvSpPr txBox="1"/>
-          <p:nvPr/>
-        </p:nvSpPr>
-        <p:spPr>
-          <a:xfrm>
-            <a:off x="9875520" y="3547872"/>
-            <a:ext cx="1691640" cy="274320"/>
-          </a:xfrm>
-          <a:prstGeom prst="rect">
-            <a:avLst/>
-          </a:prstGeom>
-          <a:noFill/>
-          <a:ln/>
-        </p:spPr>
-        <p:txBody>
-          <a:bodyPr wrap="square" lIns="0" tIns="0" rIns="0" bIns="0" rtlCol="0" anchor="ctr"/>
-          <a:lstStyle/>
-          <a:p>
-            <a:pPr algn="ctr" indent="0" marL="0">
-              <a:buNone/>
-            </a:pPr>
-            <a:r>
-              <a:rPr lang="en-US" sz="1400" b="1" dirty="0">
-                <a:solidFill>
-                  <a:srgbClr val="0B2C4A"/>
-                </a:solidFill>
-                <a:latin typeface="Inter" pitchFamily="34" charset="0"/>
-                <a:ea typeface="Inter" pitchFamily="34" charset="-122"/>
-                <a:cs typeface="Inter" pitchFamily="34" charset="-120"/>
-              </a:rPr>
-              <a:t>Service manager</a:t>
-            </a:r>
-            <a:endParaRPr lang="en-US" sz="1400" dirty="0"/>
-          </a:p>
-        </p:txBody>
-      </p:sp>
-      <p:sp>
-        <p:nvSpPr>
-          <p:cNvPr id="33" name="Shape 31"/>
+            <a:endParaRPr lang="en-US" sz="1600" dirty="0"/>
+          </a:p>
+        </p:txBody>
+      </p:sp>
+      <p:sp>
+        <p:nvSpPr>
+          <p:cNvPr id="24" name="Shape 22"/>
           <p:cNvSpPr/>
           <p:nvPr/>
         </p:nvSpPr>
@@ -1906,7 +1603,7 @@
       </p:sp>
       <p:sp>
         <p:nvSpPr>
-          <p:cNvPr id="34" name="Shape 32"/>
+          <p:cNvPr id="25" name="Shape 23"/>
           <p:cNvSpPr/>
           <p:nvPr/>
         </p:nvSpPr>
@@ -1926,7 +1623,7 @@
       </p:sp>
       <p:sp>
         <p:nvSpPr>
-          <p:cNvPr id="35" name="Text 33"/>
+          <p:cNvPr id="26" name="Text 24"/>
           <p:cNvSpPr txBox="1"/>
           <p:nvPr/>
         </p:nvSpPr>
@@ -1965,7 +1662,7 @@
       </p:sp>
       <p:sp>
         <p:nvSpPr>
-          <p:cNvPr id="36" name="Text 34"/>
+          <p:cNvPr id="27" name="Text 25"/>
           <p:cNvSpPr txBox="1"/>
           <p:nvPr/>
         </p:nvSpPr>
@@ -2004,14 +1701,14 @@
       </p:sp>
       <p:sp>
         <p:nvSpPr>
-          <p:cNvPr id="37" name="Text 35"/>
+          <p:cNvPr id="28" name="Text 26"/>
           <p:cNvSpPr txBox="1"/>
           <p:nvPr/>
         </p:nvSpPr>
         <p:spPr>
           <a:xfrm>
             <a:off x="7178040" y="4114800"/>
-            <a:ext cx="2606040" cy="713232"/>
+            <a:ext cx="4389120" cy="713232"/>
           </a:xfrm>
           <a:prstGeom prst="rect">
             <a:avLst/>
@@ -2027,7 +1724,7 @@
               <a:buNone/>
             </a:pPr>
             <a:r>
-              <a:rPr lang="en-US" sz="1400" dirty="0">
+              <a:rPr lang="en-US" sz="1600" dirty="0">
                 <a:solidFill>
                   <a:srgbClr val="595959"/>
                 </a:solidFill>
@@ -2037,145 +1734,13 @@
               </a:rPr>
               <a:t>Phones, scheduler, retention, marketing</a:t>
             </a:r>
-            <a:endParaRPr lang="en-US" sz="1400" dirty="0"/>
-          </a:p>
-        </p:txBody>
-      </p:sp>
-      <p:sp>
-        <p:nvSpPr>
-          <p:cNvPr id="38" name="Shape 36"/>
-          <p:cNvSpPr/>
-          <p:nvPr/>
-        </p:nvSpPr>
-        <p:spPr>
-          <a:xfrm>
-            <a:off x="9875520" y="4169664"/>
-            <a:ext cx="566928" cy="274320"/>
-          </a:xfrm>
-          <a:prstGeom prst="roundRect">
-            <a:avLst>
-              <a:gd name="adj" fmla="val 20000"/>
-            </a:avLst>
-          </a:prstGeom>
-          <a:solidFill>
-            <a:srgbClr val="0B2C4A"/>
-          </a:solidFill>
-          <a:ln w="9525">
-            <a:solidFill>
-              <a:srgbClr val="0B2C4A"/>
-            </a:solidFill>
-            <a:prstDash val="solid"/>
-          </a:ln>
-        </p:spPr>
-      </p:sp>
-      <p:sp>
-        <p:nvSpPr>
-          <p:cNvPr id="39" name="Text 37"/>
-          <p:cNvSpPr txBox="1"/>
-          <p:nvPr/>
-        </p:nvSpPr>
-        <p:spPr>
-          <a:xfrm>
-            <a:off x="9875520" y="4169664"/>
-            <a:ext cx="566928" cy="274320"/>
-          </a:xfrm>
-          <a:prstGeom prst="rect">
-            <a:avLst/>
-          </a:prstGeom>
-          <a:noFill/>
-          <a:ln/>
-        </p:spPr>
-        <p:txBody>
-          <a:bodyPr wrap="square" lIns="0" tIns="0" rIns="0" bIns="0" rtlCol="0" anchor="ctr"/>
-          <a:lstStyle/>
-          <a:p>
-            <a:pPr algn="ctr" indent="0" marL="0">
-              <a:buNone/>
-            </a:pPr>
-            <a:r>
-              <a:rPr lang="en-US" sz="1400" b="1" dirty="0">
-                <a:solidFill>
-                  <a:srgbClr val="FFFFFF"/>
-                </a:solidFill>
-                <a:latin typeface="Inter" pitchFamily="34" charset="0"/>
-                <a:ea typeface="Inter" pitchFamily="34" charset="-122"/>
-                <a:cs typeface="Inter" pitchFamily="34" charset="-120"/>
-              </a:rPr>
-              <a:t>GM</a:t>
-            </a:r>
-            <a:endParaRPr lang="en-US" sz="1400" dirty="0"/>
-          </a:p>
-        </p:txBody>
-      </p:sp>
-      <p:sp>
-        <p:nvSpPr>
-          <p:cNvPr id="40" name="Shape 38"/>
-          <p:cNvSpPr/>
-          <p:nvPr/>
-        </p:nvSpPr>
-        <p:spPr>
-          <a:xfrm>
-            <a:off x="9875520" y="4498848"/>
-            <a:ext cx="1691640" cy="274320"/>
-          </a:xfrm>
-          <a:prstGeom prst="roundRect">
-            <a:avLst>
-              <a:gd name="adj" fmla="val 20000"/>
-            </a:avLst>
-          </a:prstGeom>
-          <a:solidFill>
-            <a:srgbClr val="EDF4FA"/>
-          </a:solidFill>
-          <a:ln w="9525">
-            <a:solidFill>
-              <a:srgbClr val="0B2C4A"/>
-            </a:solidFill>
-            <a:prstDash val="solid"/>
-          </a:ln>
-        </p:spPr>
-      </p:sp>
-      <p:sp>
-        <p:nvSpPr>
-          <p:cNvPr id="41" name="Text 39"/>
-          <p:cNvSpPr txBox="1"/>
-          <p:nvPr/>
-        </p:nvSpPr>
-        <p:spPr>
-          <a:xfrm>
-            <a:off x="9875520" y="4498848"/>
-            <a:ext cx="1691640" cy="274320"/>
-          </a:xfrm>
-          <a:prstGeom prst="rect">
-            <a:avLst/>
-          </a:prstGeom>
-          <a:noFill/>
-          <a:ln/>
-        </p:spPr>
-        <p:txBody>
-          <a:bodyPr wrap="square" lIns="0" tIns="0" rIns="0" bIns="0" rtlCol="0" anchor="ctr"/>
-          <a:lstStyle/>
-          <a:p>
-            <a:pPr algn="ctr" indent="0" marL="0">
-              <a:buNone/>
-            </a:pPr>
-            <a:r>
-              <a:rPr lang="en-US" sz="1400" b="1" dirty="0">
-                <a:solidFill>
-                  <a:srgbClr val="0B2C4A"/>
-                </a:solidFill>
-                <a:latin typeface="Inter" pitchFamily="34" charset="0"/>
-                <a:ea typeface="Inter" pitchFamily="34" charset="-122"/>
-                <a:cs typeface="Inter" pitchFamily="34" charset="-120"/>
-              </a:rPr>
-              <a:t>Service manager</a:t>
-            </a:r>
-            <a:endParaRPr lang="en-US" sz="1400" dirty="0"/>
-          </a:p>
-        </p:txBody>
-      </p:sp>
-      <p:sp>
-        <p:nvSpPr>
-          <p:cNvPr id="42" name="Shape 40"/>
+            <a:endParaRPr lang="en-US" sz="1600" dirty="0"/>
+          </a:p>
+        </p:txBody>
+      </p:sp>
+      <p:sp>
+        <p:nvSpPr>
+          <p:cNvPr id="29" name="Shape 27"/>
           <p:cNvSpPr/>
           <p:nvPr/>
         </p:nvSpPr>
@@ -2195,7 +1760,7 @@
       </p:sp>
       <p:sp>
         <p:nvSpPr>
-          <p:cNvPr id="43" name="Shape 41"/>
+          <p:cNvPr id="30" name="Shape 28"/>
           <p:cNvSpPr/>
           <p:nvPr/>
         </p:nvSpPr>
@@ -2215,7 +1780,7 @@
       </p:sp>
       <p:sp>
         <p:nvSpPr>
-          <p:cNvPr id="44" name="Text 42"/>
+          <p:cNvPr id="31" name="Text 29"/>
           <p:cNvSpPr txBox="1"/>
           <p:nvPr/>
         </p:nvSpPr>
@@ -2246,7 +1811,7 @@
                 <a:ea typeface="Inter" pitchFamily="34" charset="-122"/>
                 <a:cs typeface="Inter" pitchFamily="34" charset="-120"/>
               </a:rPr>
-              <a:t>One minute a day saved for every tech</a:t>
+              <a:t>Ten minutes a day saved for every tech</a:t>
             </a:r>
             <a:endParaRPr lang="en-US" sz="1700" dirty="0"/>
           </a:p>
@@ -2254,7 +1819,7 @@
       </p:sp>
       <p:sp>
         <p:nvSpPr>
-          <p:cNvPr id="45" name="Text 43"/>
+          <p:cNvPr id="32" name="Text 30"/>
           <p:cNvSpPr txBox="1"/>
           <p:nvPr/>
         </p:nvSpPr>
@@ -2285,7 +1850,7 @@
                 <a:ea typeface="Inter" pitchFamily="34" charset="-122"/>
                 <a:cs typeface="Inter" pitchFamily="34" charset="-120"/>
               </a:rPr>
-              <a:t>$444,380</a:t>
+              <a:t>$4,443,804</a:t>
             </a:r>
             <a:endParaRPr lang="en-US" sz="2400" dirty="0"/>
           </a:p>
@@ -2293,14 +1858,14 @@
       </p:sp>
       <p:sp>
         <p:nvSpPr>
-          <p:cNvPr id="46" name="Text 44"/>
+          <p:cNvPr id="33" name="Text 31"/>
           <p:cNvSpPr txBox="1"/>
           <p:nvPr/>
         </p:nvSpPr>
         <p:spPr>
           <a:xfrm>
             <a:off x="7178040" y="4901184"/>
-            <a:ext cx="2606040" cy="713232"/>
+            <a:ext cx="4389120" cy="713232"/>
           </a:xfrm>
           <a:prstGeom prst="rect">
             <a:avLst/>
@@ -2316,7 +1881,7 @@
               <a:buNone/>
             </a:pPr>
             <a:r>
-              <a:rPr lang="en-US" sz="1400" dirty="0">
+              <a:rPr lang="en-US" sz="1600" dirty="0">
                 <a:solidFill>
                   <a:srgbClr val="595959"/>
                 </a:solidFill>
@@ -2326,145 +1891,13 @@
               </a:rPr>
               <a:t>Parts to the bay, tools and keys in place</a:t>
             </a:r>
-            <a:endParaRPr lang="en-US" sz="1400" dirty="0"/>
-          </a:p>
-        </p:txBody>
-      </p:sp>
-      <p:sp>
-        <p:nvSpPr>
-          <p:cNvPr id="47" name="Shape 45"/>
-          <p:cNvSpPr/>
-          <p:nvPr/>
-        </p:nvSpPr>
-        <p:spPr>
-          <a:xfrm>
-            <a:off x="9875520" y="4956048"/>
-            <a:ext cx="1691640" cy="274320"/>
-          </a:xfrm>
-          <a:prstGeom prst="roundRect">
-            <a:avLst>
-              <a:gd name="adj" fmla="val 20000"/>
-            </a:avLst>
-          </a:prstGeom>
-          <a:solidFill>
-            <a:srgbClr val="EDF4FA"/>
-          </a:solidFill>
-          <a:ln w="9525">
-            <a:solidFill>
-              <a:srgbClr val="0B2C4A"/>
-            </a:solidFill>
-            <a:prstDash val="solid"/>
-          </a:ln>
-        </p:spPr>
-      </p:sp>
-      <p:sp>
-        <p:nvSpPr>
-          <p:cNvPr id="48" name="Text 46"/>
-          <p:cNvSpPr txBox="1"/>
-          <p:nvPr/>
-        </p:nvSpPr>
-        <p:spPr>
-          <a:xfrm>
-            <a:off x="9875520" y="4956048"/>
-            <a:ext cx="1691640" cy="274320"/>
-          </a:xfrm>
-          <a:prstGeom prst="rect">
-            <a:avLst/>
-          </a:prstGeom>
-          <a:noFill/>
-          <a:ln/>
-        </p:spPr>
-        <p:txBody>
-          <a:bodyPr wrap="square" lIns="0" tIns="0" rIns="0" bIns="0" rtlCol="0" anchor="ctr"/>
-          <a:lstStyle/>
-          <a:p>
-            <a:pPr algn="ctr" indent="0" marL="0">
-              <a:buNone/>
-            </a:pPr>
-            <a:r>
-              <a:rPr lang="en-US" sz="1400" b="1" dirty="0">
-                <a:solidFill>
-                  <a:srgbClr val="0B2C4A"/>
-                </a:solidFill>
-                <a:latin typeface="Inter" pitchFamily="34" charset="0"/>
-                <a:ea typeface="Inter" pitchFamily="34" charset="-122"/>
-                <a:cs typeface="Inter" pitchFamily="34" charset="-120"/>
-              </a:rPr>
-              <a:t>Service manager</a:t>
-            </a:r>
-            <a:endParaRPr lang="en-US" sz="1400" dirty="0"/>
-          </a:p>
-        </p:txBody>
-      </p:sp>
-      <p:sp>
-        <p:nvSpPr>
-          <p:cNvPr id="49" name="Shape 47"/>
-          <p:cNvSpPr/>
-          <p:nvPr/>
-        </p:nvSpPr>
-        <p:spPr>
-          <a:xfrm>
-            <a:off x="9875520" y="5285232"/>
-            <a:ext cx="566928" cy="274320"/>
-          </a:xfrm>
-          <a:prstGeom prst="roundRect">
-            <a:avLst>
-              <a:gd name="adj" fmla="val 20000"/>
-            </a:avLst>
-          </a:prstGeom>
-          <a:solidFill>
-            <a:srgbClr val="0B2C4A"/>
-          </a:solidFill>
-          <a:ln w="9525">
-            <a:solidFill>
-              <a:srgbClr val="0B2C4A"/>
-            </a:solidFill>
-            <a:prstDash val="solid"/>
-          </a:ln>
-        </p:spPr>
-      </p:sp>
-      <p:sp>
-        <p:nvSpPr>
-          <p:cNvPr id="50" name="Text 48"/>
-          <p:cNvSpPr txBox="1"/>
-          <p:nvPr/>
-        </p:nvSpPr>
-        <p:spPr>
-          <a:xfrm>
-            <a:off x="9875520" y="5285232"/>
-            <a:ext cx="566928" cy="274320"/>
-          </a:xfrm>
-          <a:prstGeom prst="rect">
-            <a:avLst/>
-          </a:prstGeom>
-          <a:noFill/>
-          <a:ln/>
-        </p:spPr>
-        <p:txBody>
-          <a:bodyPr wrap="square" lIns="0" tIns="0" rIns="0" bIns="0" rtlCol="0" anchor="ctr"/>
-          <a:lstStyle/>
-          <a:p>
-            <a:pPr algn="ctr" indent="0" marL="0">
-              <a:buNone/>
-            </a:pPr>
-            <a:r>
-              <a:rPr lang="en-US" sz="1400" b="1" dirty="0">
-                <a:solidFill>
-                  <a:srgbClr val="FFFFFF"/>
-                </a:solidFill>
-                <a:latin typeface="Inter" pitchFamily="34" charset="0"/>
-                <a:ea typeface="Inter" pitchFamily="34" charset="-122"/>
-                <a:cs typeface="Inter" pitchFamily="34" charset="-120"/>
-              </a:rPr>
-              <a:t>GM</a:t>
-            </a:r>
-            <a:endParaRPr lang="en-US" sz="1400" dirty="0"/>
-          </a:p>
-        </p:txBody>
-      </p:sp>
-      <p:sp>
-        <p:nvSpPr>
-          <p:cNvPr id="51" name="Shape 49"/>
+            <a:endParaRPr lang="en-US" sz="1600" dirty="0"/>
+          </a:p>
+        </p:txBody>
+      </p:sp>
+      <p:sp>
+        <p:nvSpPr>
+          <p:cNvPr id="34" name="Shape 32"/>
           <p:cNvSpPr/>
           <p:nvPr/>
         </p:nvSpPr>
@@ -2484,7 +1917,7 @@
       </p:sp>
       <p:sp>
         <p:nvSpPr>
-          <p:cNvPr id="52" name="Text 50"/>
+          <p:cNvPr id="35" name="Text 33"/>
           <p:cNvSpPr txBox="1"/>
           <p:nvPr/>
         </p:nvSpPr>

</xml_diff>

<commit_message>
Day 2 deck: Where the Money Is hows for hours per RO and ten minutes a day
Co-Authored-By: Claude Opus 5.5 <noreply@anthropic.com>
Claude-Session: https://claude.ai/code/session_01Xa4nFVxuQGXmHARGph9WhS
</commit_message>
<xml_diff>
--- a/day2-deck/decks/Where the Money Is - Review.pptx
+++ b/day2-deck/decks/Where the Money Is - Review.pptx
@@ -1418,7 +1418,7 @@
                 <a:ea typeface="Inter" pitchFamily="34" charset="-122"/>
                 <a:cs typeface="Inter" pitchFamily="34" charset="-120"/>
               </a:rPr>
-              <a:t>MPI on every car, the menu, Road to the Sale</a:t>
+              <a:t>Be consistent: MPI and Road to the Sale on every car</a:t>
             </a:r>
             <a:endParaRPr lang="en-US" sz="1500" dirty="0"/>
           </a:p>
@@ -1889,7 +1889,7 @@
                 <a:ea typeface="Inter" pitchFamily="34" charset="-122"/>
                 <a:cs typeface="Inter" pitchFamily="34" charset="-120"/>
               </a:rPr>
-              <a:t>Parts to the bay, tools and keys in place</a:t>
+              <a:t>Streamline the process, remove inefficiencies: parts to the bay, tools and keys in place</a:t>
             </a:r>
             <a:endParaRPr lang="en-US" sz="1500" dirty="0"/>
           </a:p>

</xml_diff>